<commit_message>
Speaker 2 slides: add case illustrations, drop template table, switch to Times New Roman
Co-Authored-By: Claude Sonnet 5.5 <noreply@anthropic.com>
Claude-Session: https://claude.ai/code/session_01Lx1Twscw41wCKBVfzYKUb6
</commit_message>
<xml_diff>
--- a/Speaker2_slides.pptx
+++ b/Speaker2_slides.pptx
@@ -171,8 +171,8 @@
           <a:p>
             <a:pPr rtl="0"/>
             <a:endParaRPr lang="zh-CN" altLang="en-US" dirty="0">
-              <a:latin typeface="Microsoft YaHei UI" panose="020B0503020204020204" pitchFamily="34" charset="-122"/>
-              <a:ea typeface="Microsoft YaHei UI" panose="020B0503020204020204" pitchFamily="34" charset="-122"/>
+              <a:latin typeface="Times New Roman" panose="020B0503020204020204" pitchFamily="34" charset="-122"/>
+              <a:ea typeface="Times New Roman" panose="020B0503020204020204" pitchFamily="34" charset="-122"/>
             </a:endParaRPr>
           </a:p>
         </p:txBody>
@@ -207,13 +207,13 @@
             <a:pPr rtl="0"/>
             <a:fld id="{F7AE3A0C-90E8-45B9-A944-5081622638CC}" type="datetime1">
               <a:rPr lang="zh-CN" altLang="en-US" smtClean="0">
-                <a:latin typeface="Microsoft YaHei UI" panose="020B0503020204020204" pitchFamily="34" charset="-122"/>
-                <a:ea typeface="Microsoft YaHei UI" panose="020B0503020204020204" pitchFamily="34" charset="-122"/>
+                <a:latin typeface="Times New Roman" panose="020B0503020204020204" pitchFamily="34" charset="-122"/>
+                <a:ea typeface="Times New Roman" panose="020B0503020204020204" pitchFamily="34" charset="-122"/>
               </a:rPr>
             </a:fld>
             <a:endParaRPr lang="zh-CN" altLang="en-US" dirty="0">
-              <a:latin typeface="Microsoft YaHei UI" panose="020B0503020204020204" pitchFamily="34" charset="-122"/>
-              <a:ea typeface="Microsoft YaHei UI" panose="020B0503020204020204" pitchFamily="34" charset="-122"/>
+              <a:latin typeface="Times New Roman" panose="020B0503020204020204" pitchFamily="34" charset="-122"/>
+              <a:ea typeface="Times New Roman" panose="020B0503020204020204" pitchFamily="34" charset="-122"/>
             </a:endParaRPr>
           </a:p>
         </p:txBody>
@@ -247,8 +247,8 @@
           <a:p>
             <a:pPr rtl="0"/>
             <a:endParaRPr lang="zh-CN" altLang="en-US" dirty="0">
-              <a:latin typeface="Microsoft YaHei UI" panose="020B0503020204020204" pitchFamily="34" charset="-122"/>
-              <a:ea typeface="Microsoft YaHei UI" panose="020B0503020204020204" pitchFamily="34" charset="-122"/>
+              <a:latin typeface="Times New Roman" panose="020B0503020204020204" pitchFamily="34" charset="-122"/>
+              <a:ea typeface="Times New Roman" panose="020B0503020204020204" pitchFamily="34" charset="-122"/>
             </a:endParaRPr>
           </a:p>
         </p:txBody>
@@ -283,13 +283,13 @@
             <a:pPr rtl="0"/>
             <a:fld id="{4C0A24AC-02A6-46A1-A072-EAC8AC25DCA5}" type="slidenum">
               <a:rPr lang="en-US" altLang="zh-CN" smtClean="0">
-                <a:latin typeface="Microsoft YaHei UI" panose="020B0503020204020204" pitchFamily="34" charset="-122"/>
-                <a:ea typeface="Microsoft YaHei UI" panose="020B0503020204020204" pitchFamily="34" charset="-122"/>
+                <a:latin typeface="Times New Roman" panose="020B0503020204020204" pitchFamily="34" charset="-122"/>
+                <a:ea typeface="Times New Roman" panose="020B0503020204020204" pitchFamily="34" charset="-122"/>
               </a:rPr>
             </a:fld>
             <a:endParaRPr lang="zh-CN" altLang="en-US" dirty="0">
-              <a:latin typeface="Microsoft YaHei UI" panose="020B0503020204020204" pitchFamily="34" charset="-122"/>
-              <a:ea typeface="Microsoft YaHei UI" panose="020B0503020204020204" pitchFamily="34" charset="-122"/>
+              <a:latin typeface="Times New Roman" panose="020B0503020204020204" pitchFamily="34" charset="-122"/>
+              <a:ea typeface="Times New Roman" panose="020B0503020204020204" pitchFamily="34" charset="-122"/>
             </a:endParaRPr>
           </a:p>
         </p:txBody>
@@ -346,15 +346,15 @@
           <a:lstStyle>
             <a:lvl1pPr algn="l">
               <a:defRPr lang="zh-CN" sz="1200">
-                <a:latin typeface="Microsoft YaHei UI" panose="020B0503020204020204" pitchFamily="34" charset="-122"/>
-                <a:ea typeface="Microsoft YaHei UI" panose="020B0503020204020204" pitchFamily="34" charset="-122"/>
+                <a:latin typeface="Times New Roman" panose="020B0503020204020204" pitchFamily="34" charset="-122"/>
+                <a:ea typeface="Times New Roman" panose="020B0503020204020204" pitchFamily="34" charset="-122"/>
               </a:defRPr>
             </a:lvl1pPr>
           </a:lstStyle>
           <a:p>
             <a:endParaRPr lang="zh-CN" altLang="en-US" noProof="0" dirty="0">
-              <a:latin typeface="Microsoft YaHei UI" panose="020B0503020204020204" pitchFamily="34" charset="-122"/>
-              <a:ea typeface="Microsoft YaHei UI" panose="020B0503020204020204" pitchFamily="34" charset="-122"/>
+              <a:latin typeface="Times New Roman" panose="020B0503020204020204" pitchFamily="34" charset="-122"/>
+              <a:ea typeface="Times New Roman" panose="020B0503020204020204" pitchFamily="34" charset="-122"/>
             </a:endParaRPr>
           </a:p>
         </p:txBody>
@@ -383,8 +383,8 @@
           <a:lstStyle>
             <a:lvl1pPr algn="r">
               <a:defRPr lang="zh-CN" sz="1200">
-                <a:latin typeface="Microsoft YaHei UI" panose="020B0503020204020204" pitchFamily="34" charset="-122"/>
-                <a:ea typeface="Microsoft YaHei UI" panose="020B0503020204020204" pitchFamily="34" charset="-122"/>
+                <a:latin typeface="Times New Roman" panose="020B0503020204020204" pitchFamily="34" charset="-122"/>
+                <a:ea typeface="Times New Roman" panose="020B0503020204020204" pitchFamily="34" charset="-122"/>
               </a:defRPr>
             </a:lvl1pPr>
           </a:lstStyle>
@@ -526,15 +526,15 @@
           <a:lstStyle>
             <a:lvl1pPr algn="l">
               <a:defRPr lang="zh-CN" sz="1200">
-                <a:latin typeface="Microsoft YaHei UI" panose="020B0503020204020204" pitchFamily="34" charset="-122"/>
-                <a:ea typeface="Microsoft YaHei UI" panose="020B0503020204020204" pitchFamily="34" charset="-122"/>
+                <a:latin typeface="Times New Roman" panose="020B0503020204020204" pitchFamily="34" charset="-122"/>
+                <a:ea typeface="Times New Roman" panose="020B0503020204020204" pitchFamily="34" charset="-122"/>
               </a:defRPr>
             </a:lvl1pPr>
           </a:lstStyle>
           <a:p>
             <a:endParaRPr lang="zh-CN" altLang="en-US" noProof="0" dirty="0">
-              <a:latin typeface="Microsoft YaHei UI" panose="020B0503020204020204" pitchFamily="34" charset="-122"/>
-              <a:ea typeface="Microsoft YaHei UI" panose="020B0503020204020204" pitchFamily="34" charset="-122"/>
+              <a:latin typeface="Times New Roman" panose="020B0503020204020204" pitchFamily="34" charset="-122"/>
+              <a:ea typeface="Times New Roman" panose="020B0503020204020204" pitchFamily="34" charset="-122"/>
             </a:endParaRPr>
           </a:p>
         </p:txBody>
@@ -563,8 +563,8 @@
           <a:lstStyle>
             <a:lvl1pPr algn="r">
               <a:defRPr lang="zh-CN" sz="1200">
-                <a:latin typeface="Microsoft YaHei UI" panose="020B0503020204020204" pitchFamily="34" charset="-122"/>
-                <a:ea typeface="Microsoft YaHei UI" panose="020B0503020204020204" pitchFamily="34" charset="-122"/>
+                <a:latin typeface="Times New Roman" panose="020B0503020204020204" pitchFamily="34" charset="-122"/>
+                <a:ea typeface="Times New Roman" panose="020B0503020204020204" pitchFamily="34" charset="-122"/>
               </a:defRPr>
             </a:lvl1pPr>
           </a:lstStyle>
@@ -573,8 +573,8 @@
               <a:rPr lang="en-US" altLang="zh-CN" noProof="0" smtClean="0"/>
             </a:fld>
             <a:endParaRPr lang="zh-CN" altLang="en-US" noProof="0" dirty="0">
-              <a:latin typeface="Microsoft YaHei UI" panose="020B0503020204020204" pitchFamily="34" charset="-122"/>
-              <a:ea typeface="Microsoft YaHei UI" panose="020B0503020204020204" pitchFamily="34" charset="-122"/>
+              <a:latin typeface="Times New Roman" panose="020B0503020204020204" pitchFamily="34" charset="-122"/>
+              <a:ea typeface="Times New Roman" panose="020B0503020204020204" pitchFamily="34" charset="-122"/>
             </a:endParaRPr>
           </a:p>
         </p:txBody>
@@ -588,8 +588,8 @@
         <a:solidFill>
           <a:schemeClr val="tx1"/>
         </a:solidFill>
-        <a:latin typeface="Microsoft YaHei UI" panose="020B0503020204020204" pitchFamily="34" charset="-122"/>
-        <a:ea typeface="Microsoft YaHei UI" panose="020B0503020204020204" pitchFamily="34" charset="-122"/>
+        <a:latin typeface="Times New Roman" panose="020B0503020204020204" pitchFamily="34" charset="-122"/>
+        <a:ea typeface="Times New Roman" panose="020B0503020204020204" pitchFamily="34" charset="-122"/>
         <a:cs typeface="+mn-cs"/>
       </a:defRPr>
     </a:lvl1pPr>
@@ -598,8 +598,8 @@
         <a:solidFill>
           <a:schemeClr val="tx1"/>
         </a:solidFill>
-        <a:latin typeface="Microsoft YaHei UI" panose="020B0503020204020204" pitchFamily="34" charset="-122"/>
-        <a:ea typeface="Microsoft YaHei UI" panose="020B0503020204020204" pitchFamily="34" charset="-122"/>
+        <a:latin typeface="Times New Roman" panose="020B0503020204020204" pitchFamily="34" charset="-122"/>
+        <a:ea typeface="Times New Roman" panose="020B0503020204020204" pitchFamily="34" charset="-122"/>
         <a:cs typeface="+mn-cs"/>
       </a:defRPr>
     </a:lvl2pPr>
@@ -608,8 +608,8 @@
         <a:solidFill>
           <a:schemeClr val="tx1"/>
         </a:solidFill>
-        <a:latin typeface="Microsoft YaHei UI" panose="020B0503020204020204" pitchFamily="34" charset="-122"/>
-        <a:ea typeface="Microsoft YaHei UI" panose="020B0503020204020204" pitchFamily="34" charset="-122"/>
+        <a:latin typeface="Times New Roman" panose="020B0503020204020204" pitchFamily="34" charset="-122"/>
+        <a:ea typeface="Times New Roman" panose="020B0503020204020204" pitchFamily="34" charset="-122"/>
         <a:cs typeface="+mn-cs"/>
       </a:defRPr>
     </a:lvl3pPr>
@@ -618,8 +618,8 @@
         <a:solidFill>
           <a:schemeClr val="tx1"/>
         </a:solidFill>
-        <a:latin typeface="Microsoft YaHei UI" panose="020B0503020204020204" pitchFamily="34" charset="-122"/>
-        <a:ea typeface="Microsoft YaHei UI" panose="020B0503020204020204" pitchFamily="34" charset="-122"/>
+        <a:latin typeface="Times New Roman" panose="020B0503020204020204" pitchFamily="34" charset="-122"/>
+        <a:ea typeface="Times New Roman" panose="020B0503020204020204" pitchFamily="34" charset="-122"/>
         <a:cs typeface="+mn-cs"/>
       </a:defRPr>
     </a:lvl4pPr>
@@ -628,8 +628,8 @@
         <a:solidFill>
           <a:schemeClr val="tx1"/>
         </a:solidFill>
-        <a:latin typeface="Microsoft YaHei UI" panose="020B0503020204020204" pitchFamily="34" charset="-122"/>
-        <a:ea typeface="Microsoft YaHei UI" panose="020B0503020204020204" pitchFamily="34" charset="-122"/>
+        <a:latin typeface="Times New Roman" panose="020B0503020204020204" pitchFamily="34" charset="-122"/>
+        <a:ea typeface="Times New Roman" panose="020B0503020204020204" pitchFamily="34" charset="-122"/>
         <a:cs typeface="+mn-cs"/>
       </a:defRPr>
     </a:lvl5pPr>
@@ -989,6 +989,12 @@
               <a:t>Was this only a Tang habit? Case two says no. The Suishu mostly describes events, not conversations. Yet it keeps the answer of a Yamato envoy in AD 600. Asked about Japanese customs, he said his ruler saw Heaven as her elder brother and the sun as her younger brother. Lung thinks this answer came through an interpreter and went almost straight into the history. So the practice is older than the Tang.</a:t>
             </a:r>
           </a:p>
+          <a:p/>
+          <a:p>
+            <a:r>
+              <a:t>(Picture: the Yamato envoy as painted in the Liang Zhigong Tu, which is older than the Sui account. Public domain, Wikimedia Commons.)</a:t>
+            </a:r>
+          </a:p>
         </p:txBody>
       </p:sp>
       <p:sp>
@@ -1173,6 +1179,12 @@
               <a:t>Case one comes from the Tang itself: the Kirghiz envoys in AD 843. The Xin Tangshu says the emperor told an interpreter to ask about the Kirghiz land and customs. Then the chief minister, Li Deyu, sent in a report with a painting of the envoys. Here we see the whole mechanism at work: interview, pictures, report. And notice this: the interpreter asks the questions himself. He does more than pass on words.</a:t>
             </a:r>
           </a:p>
+          <a:p/>
+          <a:p>
+            <a:r>
+              <a:t>(Picture: a Tang painting of a different envoy, the Tibetan envoy, with an interpreter at far left. The Kirghiz painting is lost. Public domain, Wikimedia Commons.)</a:t>
+            </a:r>
+          </a:p>
         </p:txBody>
       </p:sp>
       <p:sp>
@@ -1260,6 +1272,12 @@
           <a:p>
             <a:r>
               <a:t>Case three is the strongest, and older still: the Liang dynasty. The Zhigong Tu, a painting from the sixth century, has short texts about thirteen countries. They follow the same list of questions as the Tang interviews. Lung compared them with the Liangshu, the history of Liang, finished in AD 636. Many texts are almost the same, word for word. About 95 percent of the Hephthalite text matches, and about 90 percent of the Dengzhi text. Lung admits the numbers are rough, but such close wording is no accident.</a:t>
+            </a:r>
+          </a:p>
+          <a:p/>
+          <a:p>
+            <a:r>
+              <a:t>(Pictures: the Langya Xiu and Dengzhi envoys from the Song copy of the Zhigong Tu. Public domain, Wikimedia Commons.)</a:t>
             </a:r>
           </a:p>
         </p:txBody>
@@ -1977,10 +1995,10 @@
               </a:solidFill>
               <a:effectLst/>
               <a:uFillTx/>
-              <a:latin typeface="Microsoft YaHei UI"/>
-              <a:ea typeface="Helvetica Neue Medium"/>
-              <a:cs typeface="Microsoft YaHei UI"/>
-              <a:sym typeface="Helvetica Neue Medium"/>
+              <a:latin typeface="Times New Roman"/>
+              <a:ea typeface="Times New Roman"/>
+              <a:cs typeface="Times New Roman"/>
+              <a:sym typeface="Times New Roman"/>
             </a:endParaRPr>
           </a:p>
         </p:txBody>
@@ -2428,10 +2446,10 @@
               </a:solidFill>
               <a:effectLst/>
               <a:uFillTx/>
-              <a:latin typeface="Microsoft YaHei UI"/>
-              <a:ea typeface="Helvetica Neue Medium"/>
-              <a:cs typeface="Microsoft YaHei UI"/>
-              <a:sym typeface="Helvetica Neue Medium"/>
+              <a:latin typeface="Times New Roman"/>
+              <a:ea typeface="Times New Roman"/>
+              <a:cs typeface="Times New Roman"/>
+              <a:sym typeface="Times New Roman"/>
             </a:endParaRPr>
           </a:p>
         </p:txBody>
@@ -4814,10 +4832,10 @@
               </a:solidFill>
               <a:effectLst/>
               <a:uFillTx/>
-              <a:latin typeface="Microsoft YaHei UI"/>
-              <a:ea typeface="Helvetica Neue Medium"/>
-              <a:cs typeface="Microsoft YaHei UI"/>
-              <a:sym typeface="Helvetica Neue Medium"/>
+              <a:latin typeface="Times New Roman"/>
+              <a:ea typeface="Times New Roman"/>
+              <a:cs typeface="Times New Roman"/>
+              <a:sym typeface="Times New Roman"/>
             </a:endParaRPr>
           </a:p>
         </p:txBody>
@@ -4920,10 +4938,10 @@
               </a:solidFill>
               <a:effectLst/>
               <a:uFillTx/>
-              <a:latin typeface="Microsoft YaHei UI"/>
-              <a:ea typeface="Helvetica Neue Medium"/>
-              <a:cs typeface="Microsoft YaHei UI"/>
-              <a:sym typeface="Helvetica Neue Medium"/>
+              <a:latin typeface="Times New Roman"/>
+              <a:ea typeface="Times New Roman"/>
+              <a:cs typeface="Times New Roman"/>
+              <a:sym typeface="Times New Roman"/>
             </a:endParaRPr>
           </a:p>
         </p:txBody>
@@ -5492,10 +5510,10 @@
               </a:solidFill>
               <a:effectLst/>
               <a:uFillTx/>
-              <a:latin typeface="Microsoft YaHei UI"/>
-              <a:ea typeface="Helvetica Neue Medium"/>
-              <a:cs typeface="Microsoft YaHei UI"/>
-              <a:sym typeface="Helvetica Neue Medium"/>
+              <a:latin typeface="Times New Roman"/>
+              <a:ea typeface="Times New Roman"/>
+              <a:cs typeface="Times New Roman"/>
+              <a:sym typeface="Times New Roman"/>
             </a:endParaRPr>
           </a:p>
         </p:txBody>
@@ -5693,10 +5711,10 @@
               </a:solidFill>
               <a:effectLst/>
               <a:uFillTx/>
-              <a:latin typeface="Microsoft YaHei UI"/>
-              <a:ea typeface="Helvetica Neue Medium"/>
-              <a:cs typeface="Microsoft YaHei UI"/>
-              <a:sym typeface="Helvetica Neue Medium"/>
+              <a:latin typeface="Times New Roman"/>
+              <a:ea typeface="Times New Roman"/>
+              <a:cs typeface="Times New Roman"/>
+              <a:sym typeface="Times New Roman"/>
             </a:endParaRPr>
           </a:p>
         </p:txBody>
@@ -6449,7 +6467,7 @@
         <a:spcBef>
           <a:spcPts val="500"/>
         </a:spcBef>
-        <a:buFont typeface="Arial" panose="02080604020202020204" pitchFamily="34" charset="0"/>
+        <a:buFont typeface="Times New Roman"/>
         <a:buChar char="•"/>
         <a:defRPr lang="zh-CN" sz="1800" kern="1200">
           <a:solidFill>
@@ -6467,7 +6485,7 @@
         <a:spcBef>
           <a:spcPts val="500"/>
         </a:spcBef>
-        <a:buFont typeface="Arial" panose="02080604020202020204" pitchFamily="34" charset="0"/>
+        <a:buFont typeface="Times New Roman"/>
         <a:buChar char="•"/>
         <a:defRPr lang="zh-CN" sz="1800" kern="1200">
           <a:solidFill>
@@ -6485,7 +6503,7 @@
         <a:spcBef>
           <a:spcPts val="500"/>
         </a:spcBef>
-        <a:buFont typeface="Arial" panose="02080604020202020204" pitchFamily="34" charset="0"/>
+        <a:buFont typeface="Times New Roman"/>
         <a:buChar char="•"/>
         <a:defRPr lang="zh-CN" sz="1800" kern="1200">
           <a:solidFill>
@@ -6503,7 +6521,7 @@
         <a:spcBef>
           <a:spcPts val="500"/>
         </a:spcBef>
-        <a:buFont typeface="Arial" panose="02080604020202020204" pitchFamily="34" charset="0"/>
+        <a:buFont typeface="Times New Roman"/>
         <a:buChar char="•"/>
         <a:defRPr lang="zh-CN" sz="1800" kern="1200">
           <a:solidFill>
@@ -7455,55 +7473,6 @@
       </p:sp>
       <p:sp>
         <p:nvSpPr>
-          <p:cNvPr id="6" name="内容占位符 5"/>
-          <p:cNvSpPr>
-            <a:spLocks noGrp="1"/>
-          </p:cNvSpPr>
-          <p:nvPr>
-            <p:ph sz="quarter" idx="4"/>
-          </p:nvPr>
-        </p:nvSpPr>
-        <p:spPr>
-          <a:xfrm>
-            <a:off x="7105342" y="2198914"/>
-            <a:ext cx="3970218" cy="3445987"/>
-          </a:xfrm>
-        </p:spPr>
-        <p:txBody>
-          <a:bodyPr rtlCol="0"/>
-          <a:lstStyle>
-            <a:defPPr>
-              <a:defRPr lang="zh-CN"/>
-            </a:defPPr>
-          </a:lstStyle>
-          <a:p>
-            <a:pPr rtl="0"/>
-            <a:r>
-              <a:rPr lang="zh-CN" dirty="0"/>
-              <a:t>The whole mechanism at work</a:t>
-            </a:r>
-            <a:endParaRPr lang="zh-CN" dirty="0"/>
-          </a:p>
-          <a:p>
-            <a:pPr rtl="0"/>
-            <a:r>
-              <a:rPr lang="zh-CN" dirty="0"/>
-              <a:t>The interpreter asks the questions himself</a:t>
-            </a:r>
-            <a:endParaRPr lang="zh-CN" dirty="0"/>
-          </a:p>
-          <a:p>
-            <a:pPr rtl="0"/>
-            <a:r>
-              <a:rPr lang="zh-CN" dirty="0"/>
-              <a:t>He does more than pass on words</a:t>
-            </a:r>
-            <a:endParaRPr lang="zh-CN" dirty="0"/>
-          </a:p>
-        </p:txBody>
-      </p:sp>
-      <p:sp>
-        <p:nvSpPr>
           <p:cNvPr id="33" name="灯片编号占位符 32"/>
           <p:cNvSpPr>
             <a:spLocks noGrp="1"/>
@@ -7547,7 +7516,7 @@
         <p:spPr>
           <a:xfrm>
             <a:off x="422178" y="2198914"/>
-            <a:ext cx="5055984" cy="3455925"/>
+            <a:ext cx="4900000" cy="3455925"/>
           </a:xfrm>
         </p:spPr>
         <p:txBody>
@@ -7588,6 +7557,72 @@
               <a:t>Report from Li Deyu</a:t>
             </a:r>
             <a:endParaRPr lang="zh-CN" dirty="0"/>
+          </a:p>
+          <a:p>
+            <a:pPr lvl="1" rtl="0"/>
+            <a:r>
+              <a:rPr lang="zh-CN" dirty="0"/>
+              <a:t>The interpreter asks the questions himself, and does more than pass on words</a:t>
+            </a:r>
+            <a:endParaRPr lang="zh-CN" dirty="0"/>
+          </a:p>
+        </p:txBody>
+      </p:sp>
+      <p:pic>
+        <p:nvPicPr>
+          <p:cNvPr id="34" name="Bunian Tu" descr="Tang painting Bunian Tu: an envoy is received at court, with an interpreter standing at far left"/>
+          <p:cNvPicPr>
+            <a:picLocks noChangeAspect="1"/>
+          </p:cNvPicPr>
+          <p:nvPr/>
+        </p:nvPicPr>
+        <p:blipFill>
+          <a:blip r:embed="rId3"/>
+          <a:stretch>
+            <a:fillRect/>
+          </a:stretch>
+        </p:blipFill>
+        <p:spPr>
+          <a:xfrm>
+            <a:off x="5900000" y="2300000"/>
+            <a:ext cx="5150000" cy="2575000"/>
+          </a:xfrm>
+          <a:prstGeom prst="rect">
+            <a:avLst/>
+          </a:prstGeom>
+        </p:spPr>
+      </p:pic>
+      <p:sp>
+        <p:nvSpPr>
+          <p:cNvPr id="35" name="Bunian Tu caption"/>
+          <p:cNvSpPr txBox="1"/>
+          <p:nvPr/>
+        </p:nvSpPr>
+        <p:spPr>
+          <a:xfrm>
+            <a:off x="5900000" y="4965000"/>
+            <a:ext cx="5150000" cy="800000"/>
+          </a:xfrm>
+          <a:prstGeom prst="rect">
+            <a:avLst/>
+          </a:prstGeom>
+          <a:noFill/>
+        </p:spPr>
+        <p:txBody>
+          <a:bodyPr wrap="square" lIns="0" rIns="0">
+            <a:spAutoFit/>
+          </a:bodyPr>
+          <a:lstStyle/>
+          <a:p>
+            <a:r>
+              <a:rPr sz="1200" i="1">
+                <a:solidFill>
+                  <a:schemeClr val="tx2"/>
+                </a:solidFill>
+                <a:latin typeface="Times New Roman"/>
+              </a:rPr>
+              <a:t>A Tang court scene: Emperor Taizong receives a Tibetan envoy; the interpreter stands at far left (Bunian Tu, Palace Museum, Beijing). The Kirghiz painting has not survived.</a:t>
+            </a:r>
           </a:p>
         </p:txBody>
       </p:sp>
@@ -7662,7 +7697,7 @@
         <p:spPr>
           <a:xfrm>
             <a:off x="419106" y="2198915"/>
-            <a:ext cx="9741183" cy="3345316"/>
+            <a:ext cx="6300000" cy="3345316"/>
           </a:xfrm>
         </p:spPr>
         <p:txBody>
@@ -7869,6 +7904,64 @@
           </a:p>
         </p:txBody>
       </p:sp>
+      <p:pic>
+        <p:nvPicPr>
+          <p:cNvPr id="36" name="Yamato envoy" descr="Portrait of a Yamato envoy with a column of text, from the Zhigong Tu"/>
+          <p:cNvPicPr>
+            <a:picLocks noChangeAspect="1"/>
+          </p:cNvPicPr>
+          <p:nvPr/>
+        </p:nvPicPr>
+        <p:blipFill>
+          <a:blip r:embed="rId3"/>
+          <a:stretch>
+            <a:fillRect/>
+          </a:stretch>
+        </p:blipFill>
+        <p:spPr>
+          <a:xfrm>
+            <a:off x="7500000" y="2200000"/>
+            <a:ext cx="1956522" cy="3000000"/>
+          </a:xfrm>
+          <a:prstGeom prst="rect">
+            <a:avLst/>
+          </a:prstGeom>
+        </p:spPr>
+      </p:pic>
+      <p:sp>
+        <p:nvSpPr>
+          <p:cNvPr id="37" name="Yamato caption"/>
+          <p:cNvSpPr txBox="1"/>
+          <p:nvPr/>
+        </p:nvSpPr>
+        <p:spPr>
+          <a:xfrm>
+            <a:off x="7500000" y="5290000"/>
+            <a:ext cx="2900000" cy="800000"/>
+          </a:xfrm>
+          <a:prstGeom prst="rect">
+            <a:avLst/>
+          </a:prstGeom>
+          <a:noFill/>
+        </p:spPr>
+        <p:txBody>
+          <a:bodyPr wrap="square" lIns="0" rIns="0">
+            <a:spAutoFit/>
+          </a:bodyPr>
+          <a:lstStyle/>
+          <a:p>
+            <a:r>
+              <a:rPr sz="1200" i="1">
+                <a:solidFill>
+                  <a:schemeClr val="tx2"/>
+                </a:solidFill>
+                <a:latin typeface="Times New Roman"/>
+              </a:rPr>
+              <a:t>Yamato envoy in the Zhigong Tu (Liang period, before the Sui)</a:t>
+            </a:r>
+          </a:p>
+        </p:txBody>
+      </p:sp>
     </p:spTree>
   </p:cSld>
   <p:clrMapOvr>
@@ -7954,15 +8047,7 @@
             <a:pPr rtl="0"/>
             <a:r>
               <a:rPr lang="zh-CN"/>
-              <a:t>A 6th-century painting with texts on 13 countries</a:t>
-            </a:r>
-            <a:endParaRPr lang="zh-CN"/>
-          </a:p>
-          <a:p>
-            <a:pPr rtl="0"/>
-            <a:r>
-              <a:rPr lang="zh-CN"/>
-              <a:t>Same question list as the Tang interviews</a:t>
+              <a:t>A 6th-century painting; its texts follow the Tang question list</a:t>
             </a:r>
             <a:endParaRPr lang="zh-CN"/>
           </a:p>
@@ -7978,336 +8063,20 @@
             <a:pPr rtl="0"/>
             <a:r>
               <a:rPr lang="zh-CN"/>
+              <a:t>Hephthalites 95%, Dengzhi 90%, Langya Xiu 85%</a:t>
+            </a:r>
+            <a:endParaRPr lang="zh-CN"/>
+          </a:p>
+          <a:p>
+            <a:pPr rtl="0"/>
+            <a:r>
+              <a:rPr lang="zh-CN"/>
               <a:t>Lung's figures are rough, but no accident</a:t>
             </a:r>
             <a:endParaRPr lang="zh-CN"/>
           </a:p>
         </p:txBody>
       </p:sp>
-      <p:graphicFrame>
-        <p:nvGraphicFramePr>
-          <p:cNvPr id="7" name="表格占位符 6"/>
-          <p:cNvGraphicFramePr>
-            <a:graphicFrameLocks noGrp="1"/>
-          </p:cNvGraphicFramePr>
-          <p:nvPr>
-            <p:ph type="tbl" sz="quarter" idx="10"/>
-          </p:nvPr>
-        </p:nvGraphicFramePr>
-        <p:xfrm>
-          <a:off x="4502150" y="2189163"/>
-          <a:ext cx="6580190" cy="3485044"/>
-        </p:xfrm>
-        <a:graphic>
-          <a:graphicData uri="http://schemas.openxmlformats.org/drawingml/2006/table">
-            <a:tbl>
-              <a:tblPr firstRow="1" bandRow="1">
-                <a:tableStyleId>{F5AB1C69-6EDB-4FF4-983F-18BD219EF322}</a:tableStyleId>
-              </a:tblPr>
-              <a:tblGrid>
-                <a:gridCol w="1900000"/>
-                <a:gridCol w="1300000"/>
-                <a:gridCol w="3380190"/>
-              </a:tblGrid>
-              <a:tr h="360407">
-                <a:tc>
-                  <a:txBody>
-                    <a:bodyPr/>
-                    <a:lstStyle>
-                      <a:defPPr>
-                        <a:defRPr lang="zh-CN"/>
-                      </a:defPPr>
-                    </a:lstStyle>
-                    <a:p>
-                      <a:pPr algn="l" rtl="0"/>
-                      <a:r>
-                        <a:rPr lang="zh-CN"/>
-                        <a:t>Country</a:t>
-                      </a:r>
-                      <a:endParaRPr lang="zh-CN"/>
-                    </a:p>
-                  </a:txBody>
-                  <a:tcPr anchor="ctr"/>
-                </a:tc>
-                <a:tc>
-                  <a:txBody>
-                    <a:bodyPr/>
-                    <a:lstStyle>
-                      <a:defPPr>
-                        <a:defRPr lang="zh-CN"/>
-                      </a:defPPr>
-                    </a:lstStyle>
-                    <a:p>
-                      <a:pPr algn="l" rtl="0"/>
-                      <a:r>
-                        <a:rPr lang="zh-CN"/>
-                        <a:t>Match</a:t>
-                      </a:r>
-                      <a:endParaRPr lang="zh-CN"/>
-                    </a:p>
-                  </a:txBody>
-                  <a:tcPr anchor="ctr"/>
-                </a:tc>
-                <a:tc>
-                  <a:txBody>
-                    <a:bodyPr/>
-                    <a:lstStyle>
-                      <a:defPPr>
-                        <a:defRPr lang="zh-CN"/>
-                      </a:defPPr>
-                    </a:lstStyle>
-                    <a:p>
-                      <a:pPr algn="l" rtl="0"/>
-                      <a:r>
-                        <a:rPr lang="zh-CN"/>
-                        <a:t>Reason for differences</a:t>
-                      </a:r>
-                      <a:endParaRPr lang="zh-CN"/>
-                    </a:p>
-                  </a:txBody>
-                  <a:tcPr anchor="ctr"/>
-                </a:tc>
-              </a:tr>
-              <a:tr h="779821">
-                <a:tc>
-                  <a:txBody>
-                    <a:bodyPr/>
-                    <a:lstStyle>
-                      <a:defPPr>
-                        <a:defRPr lang="zh-CN"/>
-                      </a:defPPr>
-                    </a:lstStyle>
-                    <a:p>
-                      <a:pPr algn="l" rtl="0"/>
-                      <a:r>
-                        <a:rPr lang="zh-CN" dirty="0"/>
-                        <a:t>Hephthalites</a:t>
-                      </a:r>
-                      <a:endParaRPr lang="zh-CN" dirty="0"/>
-                    </a:p>
-                  </a:txBody>
-                  <a:tcPr anchor="ctr"/>
-                </a:tc>
-                <a:tc>
-                  <a:txBody>
-                    <a:bodyPr/>
-                    <a:lstStyle>
-                      <a:defPPr>
-                        <a:defRPr lang="zh-CN"/>
-                      </a:defPPr>
-                    </a:lstStyle>
-                    <a:p>
-                      <a:pPr algn="l" rtl="0"/>
-                      <a:r>
-                        <a:rPr lang="zh-CN"/>
-                        <a:t>95%</a:t>
-                      </a:r>
-                      <a:endParaRPr lang="zh-CN"/>
-                    </a:p>
-                  </a:txBody>
-                  <a:tcPr anchor="ctr"/>
-                </a:tc>
-                <a:tc>
-                  <a:txBody>
-                    <a:bodyPr/>
-                    <a:lstStyle>
-                      <a:defPPr>
-                        <a:defRPr lang="zh-CN"/>
-                      </a:defPPr>
-                    </a:lstStyle>
-                    <a:p>
-                      <a:pPr algn="l" rtl="0"/>
-                      <a:r>
-                        <a:rPr lang="zh-CN"/>
-                        <a:t>Paragraphs rearranged</a:t>
-                      </a:r>
-                      <a:endParaRPr lang="zh-CN"/>
-                    </a:p>
-                  </a:txBody>
-                  <a:tcPr anchor="ctr"/>
-                </a:tc>
-              </a:tr>
-              <a:tr h="779821">
-                <a:tc>
-                  <a:txBody>
-                    <a:bodyPr/>
-                    <a:lstStyle>
-                      <a:defPPr>
-                        <a:defRPr lang="zh-CN"/>
-                      </a:defPPr>
-                    </a:lstStyle>
-                    <a:p>
-                      <a:pPr algn="l" rtl="0"/>
-                      <a:r>
-                        <a:rPr lang="zh-CN"/>
-                        <a:t>Dengzhi</a:t>
-                      </a:r>
-                      <a:endParaRPr lang="zh-CN"/>
-                    </a:p>
-                  </a:txBody>
-                  <a:tcPr anchor="ctr"/>
-                </a:tc>
-                <a:tc>
-                  <a:txBody>
-                    <a:bodyPr/>
-                    <a:lstStyle>
-                      <a:defPPr>
-                        <a:defRPr lang="zh-CN"/>
-                      </a:defPPr>
-                    </a:lstStyle>
-                    <a:p>
-                      <a:pPr algn="l" rtl="0"/>
-                      <a:r>
-                        <a:rPr lang="zh-CN"/>
-                        <a:t>90%</a:t>
-                      </a:r>
-                      <a:endParaRPr lang="zh-CN"/>
-                    </a:p>
-                  </a:txBody>
-                  <a:tcPr anchor="ctr"/>
-                </a:tc>
-                <a:tc>
-                  <a:txBody>
-                    <a:bodyPr/>
-                    <a:lstStyle>
-                      <a:defPPr>
-                        <a:defRPr lang="zh-CN"/>
-                      </a:defPPr>
-                    </a:lstStyle>
-                    <a:p>
-                      <a:pPr algn="l" rtl="0"/>
-                      <a:r>
-                        <a:rPr lang="zh-CN"/>
-                        <a:t>Style changes</a:t>
-                      </a:r>
-                      <a:endParaRPr lang="zh-CN"/>
-                    </a:p>
-                  </a:txBody>
-                  <a:tcPr anchor="ctr"/>
-                </a:tc>
-              </a:tr>
-              <a:tr h="779821">
-                <a:tc>
-                  <a:txBody>
-                    <a:bodyPr/>
-                    <a:lstStyle>
-                      <a:defPPr>
-                        <a:defRPr lang="zh-CN"/>
-                      </a:defPPr>
-                    </a:lstStyle>
-                    <a:p>
-                      <a:pPr algn="l" rtl="0"/>
-                      <a:r>
-                        <a:rPr lang="zh-CN"/>
-                        <a:t>Persia</a:t>
-                      </a:r>
-                      <a:endParaRPr lang="zh-CN"/>
-                    </a:p>
-                  </a:txBody>
-                  <a:tcPr anchor="ctr"/>
-                </a:tc>
-                <a:tc>
-                  <a:txBody>
-                    <a:bodyPr/>
-                    <a:lstStyle>
-                      <a:defPPr>
-                        <a:defRPr lang="zh-CN"/>
-                      </a:defPPr>
-                    </a:lstStyle>
-                    <a:p>
-                      <a:pPr algn="l" rtl="0"/>
-                      <a:r>
-                        <a:rPr lang="zh-CN"/>
-                        <a:t>85%</a:t>
-                      </a:r>
-                      <a:endParaRPr lang="zh-CN"/>
-                    </a:p>
-                  </a:txBody>
-                  <a:tcPr anchor="ctr"/>
-                </a:tc>
-                <a:tc>
-                  <a:txBody>
-                    <a:bodyPr/>
-                    <a:lstStyle>
-                      <a:defPPr>
-                        <a:defRPr lang="zh-CN"/>
-                      </a:defPPr>
-                    </a:lstStyle>
-                    <a:p>
-                      <a:pPr algn="l" rtl="0"/>
-                      <a:r>
-                        <a:rPr lang="zh-CN"/>
-                        <a:t>Painting vague in places</a:t>
-                      </a:r>
-                      <a:endParaRPr lang="zh-CN"/>
-                    </a:p>
-                  </a:txBody>
-                  <a:tcPr anchor="ctr"/>
-                </a:tc>
-              </a:tr>
-              <a:tr h="779821">
-                <a:tc>
-                  <a:txBody>
-                    <a:bodyPr/>
-                    <a:lstStyle>
-                      <a:defPPr>
-                        <a:defRPr lang="zh-CN"/>
-                      </a:defPPr>
-                    </a:lstStyle>
-                    <a:p>
-                      <a:pPr algn="l" rtl="0"/>
-                      <a:r>
-                        <a:rPr lang="zh-CN"/>
-                        <a:t>Langya Xiu</a:t>
-                      </a:r>
-                      <a:endParaRPr lang="zh-CN"/>
-                    </a:p>
-                  </a:txBody>
-                  <a:tcPr anchor="ctr"/>
-                </a:tc>
-                <a:tc>
-                  <a:txBody>
-                    <a:bodyPr/>
-                    <a:lstStyle>
-                      <a:defPPr>
-                        <a:defRPr lang="zh-CN"/>
-                      </a:defPPr>
-                    </a:lstStyle>
-                    <a:p>
-                      <a:pPr algn="l" rtl="0"/>
-                      <a:r>
-                        <a:rPr lang="zh-CN"/>
-                        <a:t>85%</a:t>
-                      </a:r>
-                      <a:endParaRPr lang="zh-CN"/>
-                    </a:p>
-                  </a:txBody>
-                  <a:tcPr anchor="ctr"/>
-                </a:tc>
-                <a:tc>
-                  <a:txBody>
-                    <a:bodyPr/>
-                    <a:lstStyle>
-                      <a:defPPr>
-                        <a:defRPr lang="zh-CN"/>
-                      </a:defPPr>
-                    </a:lstStyle>
-                    <a:p>
-                      <a:pPr algn="l" rtl="0"/>
-                      <a:r>
-                        <a:rPr lang="zh-CN"/>
-                        <a:t>Style changes; state letter added</a:t>
-                      </a:r>
-                      <a:endParaRPr lang="zh-CN"/>
-                    </a:p>
-                  </a:txBody>
-                  <a:tcPr anchor="ctr"/>
-                </a:tc>
-              </a:tr>
-            </a:tbl>
-          </a:graphicData>
-        </a:graphic>
-      </p:graphicFrame>
       <p:sp>
         <p:nvSpPr>
           <p:cNvPr id="13" name="灯片编号占位符 12"/>
@@ -8337,6 +8106,122 @@
               <a:rPr lang="zh-CN" smtClean="0"/>
             </a:fld>
             <a:endParaRPr lang="zh-CN" dirty="0"/>
+          </a:p>
+        </p:txBody>
+      </p:sp>
+      <p:pic>
+        <p:nvPicPr>
+          <p:cNvPr id="14" name="Langya Xiu envoy" descr="Langya Xiu envoy and its text in the Zhigong Tu"/>
+          <p:cNvPicPr>
+            <a:picLocks noChangeAspect="1"/>
+          </p:cNvPicPr>
+          <p:nvPr/>
+        </p:nvPicPr>
+        <p:blipFill>
+          <a:blip r:embed="rId3"/>
+          <a:stretch>
+            <a:fillRect/>
+          </a:stretch>
+        </p:blipFill>
+        <p:spPr>
+          <a:xfrm>
+            <a:off x="4900000" y="2200000"/>
+            <a:ext cx="2244246" cy="3000000"/>
+          </a:xfrm>
+          <a:prstGeom prst="rect">
+            <a:avLst/>
+          </a:prstGeom>
+        </p:spPr>
+      </p:pic>
+      <p:pic>
+        <p:nvPicPr>
+          <p:cNvPr id="15" name="Dengzhi envoy" descr="Dengzhi envoy and its text in the Zhigong Tu"/>
+          <p:cNvPicPr>
+            <a:picLocks noChangeAspect="1"/>
+          </p:cNvPicPr>
+          <p:nvPr/>
+        </p:nvPicPr>
+        <p:blipFill>
+          <a:blip r:embed="rId4"/>
+          <a:stretch>
+            <a:fillRect/>
+          </a:stretch>
+        </p:blipFill>
+        <p:spPr>
+          <a:xfrm>
+            <a:off x="7494246" y="2200000"/>
+            <a:ext cx="1652268" cy="3000000"/>
+          </a:xfrm>
+          <a:prstGeom prst="rect">
+            <a:avLst/>
+          </a:prstGeom>
+        </p:spPr>
+      </p:pic>
+      <p:sp>
+        <p:nvSpPr>
+          <p:cNvPr id="16" name="Langya caption"/>
+          <p:cNvSpPr txBox="1"/>
+          <p:nvPr/>
+        </p:nvSpPr>
+        <p:spPr>
+          <a:xfrm>
+            <a:off x="4900000" y="5290000"/>
+            <a:ext cx="2444246" cy="600000"/>
+          </a:xfrm>
+          <a:prstGeom prst="rect">
+            <a:avLst/>
+          </a:prstGeom>
+          <a:noFill/>
+        </p:spPr>
+        <p:txBody>
+          <a:bodyPr wrap="square" lIns="0" rIns="0">
+            <a:spAutoFit/>
+          </a:bodyPr>
+          <a:lstStyle/>
+          <a:p>
+            <a:r>
+              <a:rPr sz="1200" i="1">
+                <a:solidFill>
+                  <a:schemeClr val="tx2"/>
+                </a:solidFill>
+                <a:latin typeface="Times New Roman"/>
+              </a:rPr>
+              <a:t>Langya Xiu: about 85% match</a:t>
+            </a:r>
+          </a:p>
+        </p:txBody>
+      </p:sp>
+      <p:sp>
+        <p:nvSpPr>
+          <p:cNvPr id="17" name="Dengzhi caption"/>
+          <p:cNvSpPr txBox="1"/>
+          <p:nvPr/>
+        </p:nvSpPr>
+        <p:spPr>
+          <a:xfrm>
+            <a:off x="7494246" y="5290000"/>
+            <a:ext cx="2152268" cy="600000"/>
+          </a:xfrm>
+          <a:prstGeom prst="rect">
+            <a:avLst/>
+          </a:prstGeom>
+          <a:noFill/>
+        </p:spPr>
+        <p:txBody>
+          <a:bodyPr wrap="square" lIns="0" rIns="0">
+            <a:spAutoFit/>
+          </a:bodyPr>
+          <a:lstStyle/>
+          <a:p>
+            <a:r>
+              <a:rPr sz="1200" i="1">
+                <a:solidFill>
+                  <a:schemeClr val="tx2"/>
+                </a:solidFill>
+                <a:latin typeface="Times New Roman"/>
+              </a:rPr>
+              <a:t>Dengzhi: about 90% match</a:t>
+            </a:r>
           </a:p>
         </p:txBody>
       </p:sp>
@@ -8595,14 +8480,14 @@
     </a:clrScheme>
     <a:fontScheme name="Dante">
       <a:majorFont>
-        <a:latin typeface="Microsoft YaHei UI"/>
+        <a:latin typeface="Times New Roman"/>
         <a:ea typeface=""/>
-        <a:cs typeface="Microsoft YaHei UI"/>
+        <a:cs typeface="Times New Roman"/>
       </a:majorFont>
       <a:minorFont>
-        <a:latin typeface="Microsoft YaHei UI"/>
+        <a:latin typeface="Times New Roman"/>
         <a:ea typeface=""/>
-        <a:cs typeface="Microsoft YaHei UI"/>
+        <a:cs typeface="Times New Roman"/>
       </a:minorFont>
     </a:fontScheme>
     <a:fmtScheme name="Office">
@@ -8794,7 +8679,7 @@
     </a:clrScheme>
     <a:fontScheme name="Office">
       <a:majorFont>
-        <a:latin typeface="Calibri Light"/>
+        <a:latin typeface="Times New Roman"/>
         <a:ea typeface=""/>
         <a:cs typeface=""/>
         <a:font script="Jpan" typeface="游ゴシック Light"/>
@@ -8829,7 +8714,7 @@
         <a:font script="Geor" typeface="Sylfaen"/>
       </a:majorFont>
       <a:minorFont>
-        <a:latin typeface="Calibri"/>
+        <a:latin typeface="Times New Roman"/>
         <a:ea typeface=""/>
         <a:cs typeface=""/>
         <a:font script="Jpan" typeface="游ゴシック"/>
@@ -9053,7 +8938,7 @@
     </a:clrScheme>
     <a:fontScheme name="Office">
       <a:majorFont>
-        <a:latin typeface="Calibri Light"/>
+        <a:latin typeface="Times New Roman"/>
         <a:ea typeface=""/>
         <a:cs typeface=""/>
         <a:font script="Jpan" typeface="游ゴシック Light"/>
@@ -9088,7 +8973,7 @@
         <a:font script="Geor" typeface="Sylfaen"/>
       </a:majorFont>
       <a:minorFont>
-        <a:latin typeface="Calibri"/>
+        <a:latin typeface="Times New Roman"/>
         <a:ea typeface=""/>
         <a:cs typeface=""/>
         <a:font script="Jpan" typeface="游ゴシック"/>

</xml_diff>

<commit_message>
Speaker 2: merge steps 1-2, mechanism now summarized in three steps
Co-Authored-By: Claude Sonnet 5.5 <noreply@anthropic.com>
Claude-Session: https://claude.ai/code/session_01Lx1Twscw41wCKBVfzYKUb6
</commit_message>
<xml_diff>
--- a/Speaker2_slides.pptx
+++ b/Speaker2_slides.pptx
@@ -722,13 +722,13 @@
           <a:lstStyle/>
           <a:p>
             <a:r>
-              <a:t>After the interview comes step three: the record. The Tang Liudian says that maps of the foreign places and pictures of the envoys were drawn. Copies went to the Secretariat, and the originals stayed in the Court. A written report also went to the Bureau.</a:t>
+              <a:t>What happened after the interview? That is step two: the record. The Tang Liudian says that maps of the foreign places and pictures of the envoys were drawn. Copies went to the Secretariat, and the originals stayed in the Court. A written report also went to the Bureau.</a:t>
             </a:r>
           </a:p>
           <a:p/>
           <a:p>
             <a:r>
-              <a:t>And what did historians do with it? That is step four. We do not know if they copied the reports or changed them. But for a faraway country, the interview could be the only direct source.</a:t>
+              <a:t>And what did historians do with it? That is step three: compilation. We do not know if they copied the reports or changed them. But for a faraway country, the interview could be the only direct source.</a:t>
             </a:r>
           </a:p>
           <a:p/>
@@ -808,7 +808,7 @@
           </a:lstStyle>
           <a:p>
             <a:r>
-              <a:t>First, I will explain the institutional mechanism. It has four steps. Then I will test it with three cases.</a:t>
+              <a:t>First, I will explain the institutional mechanism. Lung does not number it, but we can sum it up in three steps. Then I will test it with three cases.</a:t>
             </a:r>
           </a:p>
         </p:txBody>
@@ -1081,13 +1081,7 @@
           </a:lstStyle>
           <a:p>
             <a:r>
-              <a:t>Step one is the interview. The Tang Huiyao says that when a mission arrived, the Court had to ask about the country's land and customs, its dress, the tribute it brought, the distance and route, and the names of its leaders.</a:t>
-            </a:r>
-          </a:p>
-          <a:p/>
-          <a:p>
-            <a:r>
-              <a:t>Now, who asked these questions, and in what language? That is step two. Sometimes officials from other offices joined too. But the envoy and the officials did not speak the same language. So everyone in the room heard the envoy through the interpreter.</a:t>
+              <a:t>Step one is the interview. The Tang Huiyao says that when a mission arrived, the Court had to ask about the country's land and customs, its dress, the tribute it brought, the distance and route, and the names of its leaders. But the envoy and the officials did not speak the same language. So everyone in the room heard the envoy through the interpreter, and his words are most likely what got written down.</a:t>
             </a:r>
           </a:p>
         </p:txBody>
@@ -6769,7 +6763,7 @@
             <a:pPr rtl="0"/>
             <a:r>
               <a:rPr lang="zh-CN"/>
-              <a:t>The Institutional Mechanism: Four Steps</a:t>
+              <a:t>The Institutional Mechanism: Three Steps</a:t>
             </a:r>
             <a:endParaRPr lang="zh-CN"/>
           </a:p>
@@ -6802,7 +6796,7 @@
             <a:pPr rtl="0"/>
             <a:r>
               <a:rPr lang="zh-CN"/>
-              <a:t>Step 1: Interview</a:t>
+              <a:t>Step 1: Interview, through the interpreter</a:t>
             </a:r>
             <a:endParaRPr lang="zh-CN"/>
           </a:p>
@@ -6810,7 +6804,7 @@
             <a:pPr rtl="0"/>
             <a:r>
               <a:rPr lang="zh-CN"/>
-              <a:t>Step 2: Interpreter</a:t>
+              <a:t>Step 2: Record</a:t>
             </a:r>
             <a:endParaRPr lang="zh-CN"/>
           </a:p>
@@ -6818,15 +6812,7 @@
             <a:pPr rtl="0"/>
             <a:r>
               <a:rPr lang="zh-CN"/>
-              <a:t>Step 3: Record</a:t>
-            </a:r>
-            <a:endParaRPr lang="zh-CN"/>
-          </a:p>
-          <a:p>
-            <a:pPr rtl="0"/>
-            <a:r>
-              <a:rPr lang="zh-CN"/>
-              <a:t>Step 4: Compilation</a:t>
+              <a:t>Step 3: Compilation</a:t>
             </a:r>
             <a:endParaRPr lang="zh-CN"/>
           </a:p>
@@ -7039,7 +7025,7 @@
             <a:pPr rtl="0"/>
             <a:r>
               <a:rPr lang="zh-CN" dirty="0"/>
-              <a:t>Steps 1–2: Interview and Interpreter</a:t>
+              <a:t>Step 1: Interview Through the Interpreter</a:t>
             </a:r>
             <a:endParaRPr lang="zh-CN" dirty="0"/>
           </a:p>
@@ -7074,7 +7060,7 @@
             <a:pPr rtl="0"/>
             <a:r>
               <a:rPr lang="zh-CN" dirty="0"/>
-              <a:t>Step 1: The Court asked every mission a fixed list of questions (Tang Huiyao):</a:t>
+              <a:t>What was asked: a fixed list of questions (Tang Huiyao)</a:t>
             </a:r>
             <a:endParaRPr lang="zh-CN" dirty="0"/>
           </a:p>
@@ -7173,7 +7159,7 @@
             <a:pPr rtl="0"/>
             <a:r>
               <a:rPr lang="zh-CN" dirty="0"/>
-              <a:t>Step 2: The envoy and the officials did not share a language.</a:t>
+              <a:t>Who spoke: the envoy and the officials did not share a language.</a:t>
             </a:r>
             <a:endParaRPr lang="zh-CN" dirty="0"/>
           </a:p>
@@ -7181,7 +7167,7 @@
             <a:pPr lvl="1" rtl="0"/>
             <a:r>
               <a:rPr lang="zh-CN" dirty="0"/>
-              <a:t>Officials from other offices sometimes joined</a:t>
+              <a:t>Everyone heard the envoy through the interpreter</a:t>
             </a:r>
             <a:endParaRPr lang="zh-CN" dirty="0"/>
           </a:p>
@@ -7189,7 +7175,7 @@
             <a:pPr lvl="1" rtl="0"/>
             <a:r>
               <a:rPr lang="zh-CN" dirty="0"/>
-              <a:t>Everyone heard the envoy through the interpreter</a:t>
+              <a:t>So the interpreter's words are most likely what got written down</a:t>
             </a:r>
             <a:endParaRPr lang="zh-CN" dirty="0"/>
           </a:p>
@@ -7249,7 +7235,7 @@
             <a:pPr rtl="0"/>
             <a:r>
               <a:rPr lang="zh-CN" dirty="0"/>
-              <a:t>Steps 3–4: Record and Compilation</a:t>
+              <a:t>Steps 2–3: Record and Compilation</a:t>
             </a:r>
             <a:endParaRPr lang="zh-CN" dirty="0"/>
           </a:p>
@@ -7284,7 +7270,7 @@
             <a:pPr rtl="0"/>
             <a:r>
               <a:rPr lang="zh-CN" dirty="0"/>
-              <a:t>Step 3: The record</a:t>
+              <a:t>Step 2: The record</a:t>
             </a:r>
             <a:endParaRPr lang="zh-CN" dirty="0"/>
           </a:p>
@@ -7383,7 +7369,7 @@
             <a:pPr rtl="0"/>
             <a:r>
               <a:rPr lang="zh-CN" dirty="0"/>
-              <a:t>Step 4: Compilation</a:t>
+              <a:t>Step 3: Compilation</a:t>
             </a:r>
             <a:endParaRPr lang="zh-CN" dirty="0"/>
           </a:p>

</xml_diff>